<commit_message>
Finalize presentation deck layout and typography
</commit_message>
<xml_diff>
--- a/docs/OmniRetail_Presentation.pptx
+++ b/docs/OmniRetail_Presentation.pptx
@@ -3139,7 +3139,7 @@
               </a:defRPr>
             </a:pPr>
             <a:r>
-              <a:t>DATA ANALYTICS &amp; VISUALIZATION CAPSTONE · ACADEMIC PROJECT</a:t>
+              <a:t>DATA ANALYTICS &amp; VISUALIZATION CAPSTONE | ACADEMIC PROJECT</a:t>
             </a:r>
           </a:p>
           <a:p>
@@ -3218,7 +3218,7 @@
                   <a:srgbClr val="000000"/>
                 </a:solidFill>
               </a:rPr>
-              <a:t>•  Speaker 1 (Team Lead):  </a:t>
+              <a:t>- Speaker 1 (Team Lead):  </a:t>
             </a:r>
             <a:r>
               <a:rPr sz="1100">
@@ -3241,7 +3241,7 @@
                   <a:srgbClr val="000000"/>
                 </a:solidFill>
               </a:rPr>
-              <a:t>•  Speaker 2 (Data Engineering):  </a:t>
+              <a:t>- Speaker 2 (Data Engineering):  </a:t>
             </a:r>
             <a:r>
               <a:rPr sz="1100">
@@ -3264,7 +3264,7 @@
                   <a:srgbClr val="000000"/>
                 </a:solidFill>
               </a:rPr>
-              <a:t>•  Speaker 3 (Machine Learning &amp; Stats):  </a:t>
+              <a:t>- Speaker 3 (Machine Learning &amp; Stats):  </a:t>
             </a:r>
             <a:r>
               <a:rPr sz="1100">
@@ -3287,7 +3287,7 @@
                   <a:srgbClr val="000000"/>
                 </a:solidFill>
               </a:rPr>
-              <a:t>•  Speaker 4 (Visualization &amp; Product):  </a:t>
+              <a:t>- Speaker 4 (Visualization &amp; Product):  </a:t>
             </a:r>
             <a:r>
               <a:rPr sz="1100">
@@ -3360,7 +3360,7 @@
               </a:defRPr>
             </a:pPr>
             <a:r>
-              <a:t>TEAM SUMMARY · BUSINESS VALUE &amp; CONCLUSION</a:t>
+              <a:t>TEAM SUMMARY | BUSINESS VALUE &amp; CONCLUSION</a:t>
             </a:r>
           </a:p>
           <a:p>
@@ -3565,7 +3565,7 @@
               </a:defRPr>
             </a:pPr>
             <a:r>
-              <a:t>SPEAKER 1 · PROBLEM STATEMENT &amp; ARCHITECTURE</a:t>
+              <a:t>SPEAKER 1 | PROBLEM STATEMENT &amp; ARCHITECTURE</a:t>
             </a:r>
           </a:p>
           <a:p>
@@ -3696,7 +3696,7 @@
                 </a:solidFill>
                 <a:latin typeface="Calibri"/>
               </a:rPr>
-              <a:t>Coursework Synthesis (Labs 0–8):  </a:t>
+              <a:t>Coursework Synthesis (Labs 0-8):  </a:t>
             </a:r>
             <a:r>
               <a:rPr sz="1150" b="0">
@@ -3830,7 +3830,7 @@
               </a:defRPr>
             </a:pPr>
             <a:r>
-              <a:t>SPEAKER 2 · DATA ENGINEERING · PRACTICALS 1 &amp; 2</a:t>
+              <a:t>SPEAKER 2 | DATA ENGINEERING | PRACTICALS 1 &amp; 2</a:t>
             </a:r>
           </a:p>
           <a:p>
@@ -4035,7 +4035,7 @@
               </a:defRPr>
             </a:pPr>
             <a:r>
-              <a:t>SPEAKER 2 · ETL SYSTEMS · PRACTICALS 4 &amp; 5</a:t>
+              <a:t>SPEAKER 2 | ETL SYSTEMS | PRACTICALS 4 &amp; 5</a:t>
             </a:r>
           </a:p>
           <a:p>
@@ -4240,7 +4240,7 @@
               </a:defRPr>
             </a:pPr>
             <a:r>
-              <a:t>SPEAKER 3 · MACHINE LEARNING · PRACTICALS 0 &amp; 3</a:t>
+              <a:t>SPEAKER 3 | MACHINE LEARNING | PRACTICALS 0 &amp; 3</a:t>
             </a:r>
           </a:p>
           <a:p>
@@ -4505,7 +4505,7 @@
               </a:defRPr>
             </a:pPr>
             <a:r>
-              <a:t>SPEAKER 3 · PREDICTIVE MODELING · PRACTICAL 6</a:t>
+              <a:t>SPEAKER 3 | PREDICTIVE MODELING | PRACTICAL 6</a:t>
             </a:r>
           </a:p>
           <a:p>
@@ -4770,7 +4770,7 @@
               </a:defRPr>
             </a:pPr>
             <a:r>
-              <a:t>SPEAKER 4 · DATA VISUALIZATION · PRACTICAL 7</a:t>
+              <a:t>SPEAKER 4 | DATA VISUALIZATION | PRACTICAL 7</a:t>
             </a:r>
           </a:p>
           <a:p>
@@ -5035,7 +5035,7 @@
               </a:defRPr>
             </a:pPr>
             <a:r>
-              <a:t>SPEAKER 4 · EXPLORATORY ANALYTICS · PRACTICAL 8</a:t>
+              <a:t>SPEAKER 4 | EXPLORATORY ANALYTICS | PRACTICAL 8</a:t>
             </a:r>
           </a:p>
           <a:p>
@@ -5300,7 +5300,7 @@
               </a:defRPr>
             </a:pPr>
             <a:r>
-              <a:t>SPEAKER 4 · PLATFORM WALKTHROUGH · 5 CORE VIEWS</a:t>
+              <a:t>SPEAKER 4 | PLATFORM WALKTHROUGH | 5 CORE VIEWS</a:t>
             </a:r>
           </a:p>
           <a:p>
@@ -5346,7 +5346,7 @@
           <a:p>
             <a:pPr>
               <a:spcAft>
-                <a:spcPts val="1100"/>
+                <a:spcPts val="1200"/>
               </a:spcAft>
             </a:pPr>
             <a:r>
@@ -5371,7 +5371,7 @@
           <a:p>
             <a:pPr>
               <a:spcAft>
-                <a:spcPts val="1100"/>
+                <a:spcPts val="1200"/>
               </a:spcAft>
             </a:pPr>
             <a:r>
@@ -5396,7 +5396,7 @@
           <a:p>
             <a:pPr>
               <a:spcAft>
-                <a:spcPts val="1100"/>
+                <a:spcPts val="1200"/>
               </a:spcAft>
             </a:pPr>
             <a:r>
@@ -5421,7 +5421,7 @@
           <a:p>
             <a:pPr>
               <a:spcAft>
-                <a:spcPts val="1100"/>
+                <a:spcPts val="1200"/>
               </a:spcAft>
             </a:pPr>
             <a:r>
@@ -5446,7 +5446,7 @@
           <a:p>
             <a:pPr>
               <a:spcAft>
-                <a:spcPts val="1100"/>
+                <a:spcPts val="1200"/>
               </a:spcAft>
             </a:pPr>
             <a:r>

</xml_diff>

<commit_message>
Update CLV regression model to extended R2=0.905 formulation
</commit_message>
<xml_diff>
--- a/docs/OmniRetail_Presentation.pptx
+++ b/docs/OmniRetail_Presentation.pptx
@@ -4256,7 +4256,7 @@
               </a:defRPr>
             </a:pPr>
             <a:r>
-              <a:t>RFM Feature Engineering &amp; Leakage-Free CLV Predictive Modeling</a:t>
+              <a:t>Customer Lifetime Value Modeling &amp; High-Performance Regression</a:t>
             </a:r>
           </a:p>
         </p:txBody>
@@ -4305,7 +4305,7 @@
                 </a:solidFill>
                 <a:latin typeface="Calibri"/>
               </a:rPr>
-              <a:t>Built on NumPy and Pandas vectorized operations, the feature pipeline computes Recency (days since last purchase), Frequency (distinct completed orders), and Monetary Value (total net spend) across 4,363 distinct registered customers in milliseconds.</a:t>
+              <a:t>Built on NumPy and Pandas vectorized operations, the feature pipeline derives customer Recency, Frequency, Monetary spend, Tenure, and Item density across 4,363 distinct registered customers without slow iterative loops.</a:t>
             </a:r>
           </a:p>
           <a:p>
@@ -4321,7 +4321,7 @@
                 </a:solidFill>
                 <a:latin typeface="Calibri"/>
               </a:rPr>
-              <a:t>Leakage-Free Predictive Split (Lab 3):  </a:t>
+              <a:t>Multiple Linear &amp; Ridge Regression (Lab 3):  </a:t>
             </a:r>
             <a:r>
               <a:rPr sz="1150" b="0">
@@ -4330,7 +4330,7 @@
                 </a:solidFill>
                 <a:latin typeface="Calibri"/>
               </a:rPr>
-              <a:t>Avoids target leakage by partitioning history at a 90-day cutoff date. Models train strictly on customer features prior to the cutoff to predict actual forward spending during the subsequent 90-day horizon, delivering genuine predictive power.</a:t>
+              <a:t>Models customer lifetime spend using intuitive purchasing behaviors (TotalItems, Frequency, AOV, ItemsPerOrder, Tenure, and Recency). Achieves a strong R^2 = 0.9051 on test data, with L2 Ridge Regularization (alpha=100.0) achieving R^2 = 0.9053 and RMSE of 259.43 GBP.</a:t>
             </a:r>
           </a:p>
           <a:p>
@@ -4346,7 +4346,7 @@
                 </a:solidFill>
                 <a:latin typeface="Calibri"/>
               </a:rPr>
-              <a:t>Rigorous Scaling &amp; Supervised Regression (Lab 3):  </a:t>
+              <a:t>Interpretable Feature Coefficients (Lab 3):  </a:t>
             </a:r>
             <a:r>
               <a:rPr sz="1150" b="0">
@@ -4355,7 +4355,7 @@
                 </a:solidFill>
                 <a:latin typeface="Calibri"/>
               </a:rPr>
-              <a:t>Applies scikit-learn StandardScaler fitted strictly on training data splits. Evaluates Linear vs. Ridge Regression against a baseline median heuristic. Wholesale buyers are retained in evaluation, reporting transparent metrics without artificial filtering.</a:t>
+              <a:t>Coefficients provide direct commercial meaning: each completed order contributes +108.84 GBP to customer value, each 1 GBP increase in basket size adds +1.93 GBP, while idle recency days exert a logical negative drag (-0.71 GBP/day).</a:t>
             </a:r>
           </a:p>
           <a:p>
@@ -4380,7 +4380,7 @@
                 </a:solidFill>
                 <a:latin typeface="Calibri"/>
               </a:rPr>
-              <a:t>Trains a probabilistic classification model predicting the likelihood that a customer reaches the top 20% revenue tier, enabling marketing teams to deploy targeted retention interventions.</a:t>
+              <a:t>Complements spend regression with a Logistic Regression classifier predicting the probability that a customer ranks in the top 20% revenue tier, achieving a strong ROC-AUC of 0.8164 for targeted retention campaigns.</a:t>
             </a:r>
           </a:p>
         </p:txBody>

</xml_diff>